<commit_message>
feat(auth): update login, signup, and reset password forms for improved styling and accessibility
fix(auth): enhance error handling in signup route and reset password form

feat(api): add new endpoints for scan history, export, and API key management

fix(api): improve error handling and response structure in scan and report routes

style: update global styles for better typography and layout consistency

refactor(auth): update auth configuration and user session handling for better type safety

chore: add new utility functions for database URL compatibility in Prisma setup

feat: implement PDF report generation for scan history export
</commit_message>
<xml_diff>
--- a/Codeunnati_Marathonrnppt.pptx
+++ b/Codeunnati_Marathonrnppt.pptx
@@ -154,7 +154,7 @@
           <a:p>
             <a:fld id="{407DA4AA-0FF9-453D-94EE-83C1792FCA55}" type="datetimeFigureOut">
               <a:rPr lang="en-IN" smtClean="0"/>
-              <a:t>23-02-2026</a:t>
+              <a:t>17-03-2026</a:t>
             </a:fld>
             <a:endParaRPr lang="en-IN"/>
           </a:p>
@@ -2662,7 +2662,7 @@
           <a:p>
             <a:fld id="{1D8BD707-D9CF-40AE-B4C6-C98DA3205C09}" type="datetimeFigureOut">
               <a:rPr lang="en-US"/>
-              <a:t>2/23/2026</a:t>
+              <a:t>3/17/2026</a:t>
             </a:fld>
             <a:endParaRPr lang="en-US"/>
           </a:p>
@@ -2831,7 +2831,7 @@
           <a:p>
             <a:fld id="{1D8BD707-D9CF-40AE-B4C6-C98DA3205C09}" type="datetimeFigureOut">
               <a:rPr lang="en-US"/>
-              <a:t>2/23/2026</a:t>
+              <a:t>3/17/2026</a:t>
             </a:fld>
             <a:endParaRPr lang="en-US"/>
           </a:p>
@@ -6077,7 +6077,7 @@
               <a:rPr lang="en-US" b="1" dirty="0">
                 <a:latin typeface="Times New Roman" panose="02020603050405020304" pitchFamily="18" charset="0"/>
                 <a:cs typeface="Times New Roman" panose="02020603050405020304" pitchFamily="18" charset="0"/>
-                <a:hlinkClick r:id="rId5" action="ppaction://hlinksldjump"/>
+                <a:hlinkClick r:id="rId5"/>
               </a:rPr>
               <a:t>https://youtu.be/Q6-LZUxMPIc</a:t>
             </a:r>

</xml_diff>